<commit_message>
refactor: update Select component to include wrapperClassName and enhance styling in Inspector and Research components
</commit_message>
<xml_diff>
--- a/presentation/16_ContextLens.pptx
+++ b/presentation/16_ContextLens.pptx
@@ -3281,6 +3281,76 @@
       <p:sp>
         <p:nvSpPr>
           <p:cNvPr id="6" name="TextBox 5"/>
+          <p:cNvSpPr txBox="1"/>
+          <p:nvPr/>
+        </p:nvSpPr>
+        <p:spPr>
+          <a:xfrm>
+            <a:off x="731520" y="5943600"/>
+            <a:ext cx="10698480" cy="365760"/>
+          </a:xfrm>
+          <a:prstGeom prst="rect">
+            <a:avLst/>
+          </a:prstGeom>
+          <a:noFill/>
+        </p:spPr>
+        <p:txBody>
+          <a:bodyPr wrap="square">
+            <a:spAutoFit/>
+          </a:bodyPr>
+          <a:lstStyle/>
+          <a:p>
+            <a:pPr algn="l"/>
+            <a:r>
+              <a:rPr sz="1500" b="0">
+                <a:solidFill>
+                  <a:srgbClr val="5B6677"/>
+                </a:solidFill>
+                <a:latin typeface="Calibri"/>
+              </a:rPr>
+              <a:t>Team: Tarang Kumar, Inderneel Saunik</a:t>
+            </a:r>
+          </a:p>
+        </p:txBody>
+      </p:sp>
+      <p:sp>
+        <p:nvSpPr>
+          <p:cNvPr id="7" name="TextBox 6"/>
+          <p:cNvSpPr txBox="1"/>
+          <p:nvPr/>
+        </p:nvSpPr>
+        <p:spPr>
+          <a:xfrm>
+            <a:off x="731520" y="6309360"/>
+            <a:ext cx="10698480" cy="365760"/>
+          </a:xfrm>
+          <a:prstGeom prst="rect">
+            <a:avLst/>
+          </a:prstGeom>
+          <a:noFill/>
+        </p:spPr>
+        <p:txBody>
+          <a:bodyPr wrap="square">
+            <a:spAutoFit/>
+          </a:bodyPr>
+          <a:lstStyle/>
+          <a:p>
+            <a:pPr algn="l"/>
+            <a:r>
+              <a:rPr sz="1500" b="0">
+                <a:solidFill>
+                  <a:srgbClr val="5B6677"/>
+                </a:solidFill>
+                <a:latin typeface="Calibri"/>
+              </a:rPr>
+              <a:t>Date: [Presentation Date]</a:t>
+            </a:r>
+          </a:p>
+        </p:txBody>
+      </p:sp>
+      <p:sp>
+        <p:nvSpPr>
+          <p:cNvPr id="8" name="TextBox 7"/>
           <p:cNvSpPr txBox="1"/>
           <p:nvPr/>
         </p:nvSpPr>

</xml_diff>